<commit_message>
Company-PC mode: configurable folders, Windows launcher, Outlook email, findings kept off git
Co-Authored-By: Claude Sonnet 5.5 <noreply@anthropic.com>
Claude-Session: https://claude.ai/code/session_01WEWGyTotqGdUKy4qo6WjHk
</commit_message>
<xml_diff>
--- a/reports/daily_cost_review.pptx
+++ b/reports/daily_cost_review.pptx
@@ -4001,7 +4001,7 @@
               </a:defRPr>
             </a:pPr>
             <a:r>
-              <a:t>Daily cost review · as of 05 Oct 2026 · variance = actual − accrual (+ = under-accrued)</a:t>
+              <a:t>Daily cost review · as of 06 Oct 2026 · variance = actual − accrual (+ = under-accrued)</a:t>
             </a:r>
           </a:p>
         </p:txBody>
@@ -6928,7 +6928,7 @@
                         <a:defRPr sz="1100"/>
                       </a:pPr>
                       <a:r>
-                        <a:t>158</a:t>
+                        <a:t>159</a:t>
                       </a:r>
                     </a:p>
                   </a:txBody>
@@ -7035,7 +7035,7 @@
                         <a:defRPr sz="1100"/>
                       </a:pPr>
                       <a:r>
-                        <a:t>97</a:t>
+                        <a:t>98</a:t>
                       </a:r>
                     </a:p>
                   </a:txBody>
@@ -7142,7 +7142,7 @@
                         <a:defRPr sz="1100"/>
                       </a:pPr>
                       <a:r>
-                        <a:t>127</a:t>
+                        <a:t>128</a:t>
                       </a:r>
                     </a:p>
                   </a:txBody>
@@ -7249,7 +7249,7 @@
                         <a:defRPr sz="1100"/>
                       </a:pPr>
                       <a:r>
-                        <a:t>97</a:t>
+                        <a:t>98</a:t>
                       </a:r>
                     </a:p>
                   </a:txBody>
@@ -7356,7 +7356,7 @@
                         <a:defRPr sz="1100"/>
                       </a:pPr>
                       <a:r>
-                        <a:t>158</a:t>
+                        <a:t>159</a:t>
                       </a:r>
                     </a:p>
                   </a:txBody>
@@ -7463,7 +7463,7 @@
                         <a:defRPr sz="1100"/>
                       </a:pPr>
                       <a:r>
-                        <a:t>97</a:t>
+                        <a:t>98</a:t>
                       </a:r>
                     </a:p>
                   </a:txBody>
@@ -7570,7 +7570,7 @@
                         <a:defRPr sz="1100"/>
                       </a:pPr>
                       <a:r>
-                        <a:t>127</a:t>
+                        <a:t>128</a:t>
                       </a:r>
                     </a:p>
                   </a:txBody>
@@ -7677,7 +7677,7 @@
                         <a:defRPr sz="1100"/>
                       </a:pPr>
                       <a:r>
-                        <a:t>97</a:t>
+                        <a:t>98</a:t>
                       </a:r>
                     </a:p>
                   </a:txBody>
@@ -7784,7 +7784,7 @@
                         <a:defRPr sz="1100"/>
                       </a:pPr>
                       <a:r>
-                        <a:t>158</a:t>
+                        <a:t>159</a:t>
                       </a:r>
                     </a:p>
                   </a:txBody>
@@ -7891,7 +7891,7 @@
                         <a:defRPr sz="1100"/>
                       </a:pPr>
                       <a:r>
-                        <a:t>97</a:t>
+                        <a:t>98</a:t>
                       </a:r>
                     </a:p>
                   </a:txBody>

</xml_diff>